<commit_message>
Add narrated captioned demo and final Firebase submission assets
</commit_message>
<xml_diff>
--- a/submission/pitch.pptx
+++ b/submission/pitch.pptx
@@ -2,21 +2,21 @@
 <file path=ppt/presentation.xml><?xml version="1.0" encoding="utf-8"?>
 <p:presentation xmlns:p="http://schemas.openxmlformats.org/presentationml/2006/main">
   <p:sldMasterIdLst>
-    <p:sldMasterId xmlns:r="http://schemas.openxmlformats.org/officeDocument/2006/relationships" id="2147483648" r:id="R6057b895255c4e41"/>
+    <p:sldMasterId xmlns:r="http://schemas.openxmlformats.org/officeDocument/2006/relationships" id="2147483648" r:id="Rf44f25d1934e4efe"/>
   </p:sldMasterIdLst>
   <p:notesMasterIdLst>
-    <p:notesMasterId xmlns:r="http://schemas.openxmlformats.org/officeDocument/2006/relationships" r:id="R60de547fc67b4e2d"/>
+    <p:notesMasterId xmlns:r="http://schemas.openxmlformats.org/officeDocument/2006/relationships" r:id="R4b1c52da3f7b412f"/>
   </p:notesMasterIdLst>
   <p:sldIdLst>
-    <p:sldId xmlns:r="http://schemas.openxmlformats.org/officeDocument/2006/relationships" id="256" r:id="R6446415ff9b849c3"/>
-    <p:sldId xmlns:r="http://schemas.openxmlformats.org/officeDocument/2006/relationships" id="257" r:id="R8aa4ed67f46e4711"/>
-    <p:sldId xmlns:r="http://schemas.openxmlformats.org/officeDocument/2006/relationships" id="258" r:id="Rd3495e3590ec4b7b"/>
-    <p:sldId xmlns:r="http://schemas.openxmlformats.org/officeDocument/2006/relationships" id="259" r:id="R4e41db4c17ca4084"/>
-    <p:sldId xmlns:r="http://schemas.openxmlformats.org/officeDocument/2006/relationships" id="260" r:id="R4de7d93c94114819"/>
-    <p:sldId xmlns:r="http://schemas.openxmlformats.org/officeDocument/2006/relationships" id="261" r:id="R71cc80631b544aff"/>
-    <p:sldId xmlns:r="http://schemas.openxmlformats.org/officeDocument/2006/relationships" id="262" r:id="Rf3fdf7cc14af4442"/>
-    <p:sldId xmlns:r="http://schemas.openxmlformats.org/officeDocument/2006/relationships" id="263" r:id="R5d411755622a4458"/>
-    <p:sldId xmlns:r="http://schemas.openxmlformats.org/officeDocument/2006/relationships" id="264" r:id="R8551feac3ee74ced"/>
+    <p:sldId xmlns:r="http://schemas.openxmlformats.org/officeDocument/2006/relationships" id="256" r:id="R13a9b22ad01a4b20"/>
+    <p:sldId xmlns:r="http://schemas.openxmlformats.org/officeDocument/2006/relationships" id="257" r:id="R974ad71ff32d4ad9"/>
+    <p:sldId xmlns:r="http://schemas.openxmlformats.org/officeDocument/2006/relationships" id="258" r:id="R615c324f39224bb5"/>
+    <p:sldId xmlns:r="http://schemas.openxmlformats.org/officeDocument/2006/relationships" id="259" r:id="R0f80630cc6104ddf"/>
+    <p:sldId xmlns:r="http://schemas.openxmlformats.org/officeDocument/2006/relationships" id="260" r:id="R0eace3bc2ad246e1"/>
+    <p:sldId xmlns:r="http://schemas.openxmlformats.org/officeDocument/2006/relationships" id="261" r:id="R495a8a8a50b54edd"/>
+    <p:sldId xmlns:r="http://schemas.openxmlformats.org/officeDocument/2006/relationships" id="262" r:id="Rda0a09240f6b482b"/>
+    <p:sldId xmlns:r="http://schemas.openxmlformats.org/officeDocument/2006/relationships" id="263" r:id="Ra3e7dc05514e479f"/>
+    <p:sldId xmlns:r="http://schemas.openxmlformats.org/officeDocument/2006/relationships" id="264" r:id="R06a4e6c1248e42a4"/>
   </p:sldIdLst>
   <p:sldSz cx="12192000" cy="6858000"/>
   <p:notesSz cx="6858000" cy="9144000"/>
@@ -800,7 +800,7 @@
           <a:lstStyle xmlns:a="http://schemas.openxmlformats.org/drawingml/2006/main"/>
           <a:p xmlns:a="http://schemas.openxmlformats.org/drawingml/2006/main">
             <a:r>
-              <a:t>Current implemented capability: exported manual prompt with exact release contract and execution evidence. Source: submission/media/recorded-bob-handoff.md and docs/BOB-WORKFLOW.md. This slide describes a proposed manual IDE workflow. It does not claim completed Bob implementation or live Bob API integration. Genuine completed-task evidence is required separately for hackathon eligibility.</a:t>
+              <a:t>Bob IDE authored tests/bob-workflow.test.ts and ran all 41 tests successfully using real PGlite. The tests inspect source-derived checkout contracts, lost post-deployment order 204, the safe candidate and invariant identity. This is a scoped testing contribution, not a claim that Bob built the entire product. A genuine Bob work capture is retained in submission/media/bob-verification-work.png. The required task consumption summary is a separate deliverable. New custom repair investigations use the manual exported evidence handoff.</a:t>
             </a:r>
           </a:p>
         </p:txBody>
@@ -1010,7 +1010,7 @@
           <a:lstStyle xmlns:a="http://schemas.openxmlformats.org/drawingml/2006/main"/>
           <a:p xmlns:a="http://schemas.openxmlformats.org/drawingml/2006/main">
             <a:r>
-              <a:t>Verified public guest demo: https://shi1720.github.io/ibm-bob/ . Public repository: https://github.com/shi1720/ibm-bob . Created by Shivam Gupta with AI-assisted development. Account history requires the included self-hosted server.</a:t>
+              <a:t>Verified hosted application: https://undoproof.web.app . Public repository: https://github.com/shi1720/ibm-bob . Created by Shivam Gupta with AI-assisted development. Firebase Authentication and Firestore support private account history. Guest SQL runs locally in the browser.</a:t>
             </a:r>
           </a:p>
         </p:txBody>
@@ -1078,7 +1078,7 @@
   </p:cSld>
   <p:clrMap bg1="lt1" tx1="dk1" bg2="lt2" tx2="dk2" accent1="accent1" accent2="accent2" accent3="accent3" accent4="accent4" accent5="accent5" accent6="accent6" hlink="hlink" folHlink="folHlink"/>
   <p:sldLayoutIdLst>
-    <p:sldLayoutId xmlns:r="http://schemas.openxmlformats.org/officeDocument/2006/relationships" id="2147483649" r:id="Rb4658a4fc1ce4435"/>
+    <p:sldLayoutId xmlns:r="http://schemas.openxmlformats.org/officeDocument/2006/relationships" id="2147483649" r:id="R62984c9ddd2348c9"/>
   </p:sldLayoutIdLst>
   <p:txStyles>
     <p:titleStyle>
@@ -1629,7 +1629,7 @@
           <p:cNvPr id="6" name="text-0">
             <a:extLst xmlns:a="http://schemas.openxmlformats.org/drawingml/2006/main">
               <a:ext uri="{FF2B5EF4-FFF2-40B4-BE49-F238E27FC236}">
-                <a16:creationId xmlns:a16="http://schemas.microsoft.com/office/drawing/2014/main" id="{A2D82C96-5D02-4106-8267-F5461C5FEAD2}"/>
+                <a16:creationId xmlns:a16="http://schemas.microsoft.com/office/drawing/2014/main" id="{0899557D-7610-4CA2-9B73-83DC239B0299}"/>
               </a:ext>
             </a:extLst>
           </p:cNvPr>
@@ -1686,7 +1686,7 @@
           <p:cNvPr id="2" name="text-1">
             <a:extLst xmlns:a="http://schemas.openxmlformats.org/drawingml/2006/main">
               <a:ext uri="{FF2B5EF4-FFF2-40B4-BE49-F238E27FC236}">
-                <a16:creationId xmlns:a16="http://schemas.microsoft.com/office/drawing/2014/main" id="{49A181BC-82BF-4184-810B-C4822C9B795B}"/>
+                <a16:creationId xmlns:a16="http://schemas.microsoft.com/office/drawing/2014/main" id="{0AEC1FD5-4BAF-4F60-A104-ECEE0483F503}"/>
               </a:ext>
             </a:extLst>
           </p:cNvPr>
@@ -1743,7 +1743,7 @@
           <p:cNvPr id="3" name="text-2">
             <a:extLst xmlns:a="http://schemas.openxmlformats.org/drawingml/2006/main">
               <a:ext uri="{FF2B5EF4-FFF2-40B4-BE49-F238E27FC236}">
-                <a16:creationId xmlns:a16="http://schemas.microsoft.com/office/drawing/2014/main" id="{37345105-F5F8-4AB2-8794-59136C94054E}"/>
+                <a16:creationId xmlns:a16="http://schemas.microsoft.com/office/drawing/2014/main" id="{A14F8EAB-B9FF-43BF-BB8E-63CEBB26A209}"/>
               </a:ext>
             </a:extLst>
           </p:cNvPr>
@@ -1800,7 +1800,7 @@
           <p:cNvPr id="4" name="text-3">
             <a:extLst xmlns:a="http://schemas.openxmlformats.org/drawingml/2006/main">
               <a:ext uri="{FF2B5EF4-FFF2-40B4-BE49-F238E27FC236}">
-                <a16:creationId xmlns:a16="http://schemas.microsoft.com/office/drawing/2014/main" id="{21850B05-5D02-4FD0-A867-7F54BE6F4C7F}"/>
+                <a16:creationId xmlns:a16="http://schemas.microsoft.com/office/drawing/2014/main" id="{04C843DC-5198-470C-98F7-2FA95A8E9FFA}"/>
               </a:ext>
             </a:extLst>
           </p:cNvPr>
@@ -1857,7 +1857,7 @@
           <p:cNvPr id="5" name="text-4">
             <a:extLst xmlns:a="http://schemas.openxmlformats.org/drawingml/2006/main">
               <a:ext uri="{FF2B5EF4-FFF2-40B4-BE49-F238E27FC236}">
-                <a16:creationId xmlns:a16="http://schemas.microsoft.com/office/drawing/2014/main" id="{253E0E19-EF8F-4DD0-A163-2073D7141734}"/>
+                <a16:creationId xmlns:a16="http://schemas.microsoft.com/office/drawing/2014/main" id="{83747DA8-1215-4D90-BF17-0C998E7FBF7F}"/>
               </a:ext>
             </a:extLst>
           </p:cNvPr>
@@ -1912,7 +1912,7 @@
     </p:spTree>
     <p:extLst>
       <p:ext uri="{BB962C8B-B14F-4D97-AF65-F5344CB8AC3E}">
-        <p14:creationId xmlns:p14="http://schemas.microsoft.com/office/powerpoint/2010/main" val="2038304667"/>
+        <p14:creationId xmlns:p14="http://schemas.microsoft.com/office/powerpoint/2010/main" val="151184110"/>
       </p:ext>
     </p:extLst>
   </p:cSld>
@@ -1943,7 +1943,7 @@
           <p:cNvPr id="7" name="text-5">
             <a:extLst xmlns:a="http://schemas.openxmlformats.org/drawingml/2006/main">
               <a:ext uri="{FF2B5EF4-FFF2-40B4-BE49-F238E27FC236}">
-                <a16:creationId xmlns:a16="http://schemas.microsoft.com/office/drawing/2014/main" id="{EAD0E266-330C-40B0-B77D-5AC63CB5E2A4}"/>
+                <a16:creationId xmlns:a16="http://schemas.microsoft.com/office/drawing/2014/main" id="{F03FA6E0-CDC2-474C-B754-A165655D0FFC}"/>
               </a:ext>
             </a:extLst>
           </p:cNvPr>
@@ -2000,7 +2000,7 @@
           <p:cNvPr id="2" name="text-6">
             <a:extLst xmlns:a="http://schemas.openxmlformats.org/drawingml/2006/main">
               <a:ext uri="{FF2B5EF4-FFF2-40B4-BE49-F238E27FC236}">
-                <a16:creationId xmlns:a16="http://schemas.microsoft.com/office/drawing/2014/main" id="{232585C4-72CA-4EA6-815B-312FA00A4EBC}"/>
+                <a16:creationId xmlns:a16="http://schemas.microsoft.com/office/drawing/2014/main" id="{68A586C6-2D53-49EE-9CD1-105BFEB9FE57}"/>
               </a:ext>
             </a:extLst>
           </p:cNvPr>
@@ -2057,7 +2057,7 @@
           <p:cNvPr id="3" name="text-7">
             <a:extLst xmlns:a="http://schemas.openxmlformats.org/drawingml/2006/main">
               <a:ext uri="{FF2B5EF4-FFF2-40B4-BE49-F238E27FC236}">
-                <a16:creationId xmlns:a16="http://schemas.microsoft.com/office/drawing/2014/main" id="{ABA81635-40F9-483B-8738-761CAD407E45}"/>
+                <a16:creationId xmlns:a16="http://schemas.microsoft.com/office/drawing/2014/main" id="{808C1D97-F6C5-4410-8B69-9E947232F9A1}"/>
               </a:ext>
             </a:extLst>
           </p:cNvPr>
@@ -2114,7 +2114,7 @@
           <p:cNvPr id="4" name="text-8">
             <a:extLst xmlns:a="http://schemas.openxmlformats.org/drawingml/2006/main">
               <a:ext uri="{FF2B5EF4-FFF2-40B4-BE49-F238E27FC236}">
-                <a16:creationId xmlns:a16="http://schemas.microsoft.com/office/drawing/2014/main" id="{D89A35C4-1CA5-4CF4-AF10-73B3A3773DC6}"/>
+                <a16:creationId xmlns:a16="http://schemas.microsoft.com/office/drawing/2014/main" id="{33CB58A0-1F41-459A-9B0F-A06ACAE10ED6}"/>
               </a:ext>
             </a:extLst>
           </p:cNvPr>
@@ -2171,7 +2171,7 @@
           <p:cNvPr id="5" name="text-9">
             <a:extLst xmlns:a="http://schemas.openxmlformats.org/drawingml/2006/main">
               <a:ext uri="{FF2B5EF4-FFF2-40B4-BE49-F238E27FC236}">
-                <a16:creationId xmlns:a16="http://schemas.microsoft.com/office/drawing/2014/main" id="{6BBF8590-49D4-4A98-9AD9-0A4A17467EE8}"/>
+                <a16:creationId xmlns:a16="http://schemas.microsoft.com/office/drawing/2014/main" id="{7F7BB814-62B2-46C4-AB6F-7E6956A7B7B6}"/>
               </a:ext>
             </a:extLst>
           </p:cNvPr>
@@ -2228,7 +2228,7 @@
           <p:cNvPr id="6" name="text-10">
             <a:extLst xmlns:a="http://schemas.openxmlformats.org/drawingml/2006/main">
               <a:ext uri="{FF2B5EF4-FFF2-40B4-BE49-F238E27FC236}">
-                <a16:creationId xmlns:a16="http://schemas.microsoft.com/office/drawing/2014/main" id="{5EF3926A-C937-485E-83BC-2F8DEBA03F60}"/>
+                <a16:creationId xmlns:a16="http://schemas.microsoft.com/office/drawing/2014/main" id="{3F46F816-A487-494B-A9FD-DEF99FCB9976}"/>
               </a:ext>
             </a:extLst>
           </p:cNvPr>
@@ -2283,7 +2283,7 @@
     </p:spTree>
     <p:extLst>
       <p:ext uri="{BB962C8B-B14F-4D97-AF65-F5344CB8AC3E}">
-        <p14:creationId xmlns:p14="http://schemas.microsoft.com/office/powerpoint/2010/main" val="813335834"/>
+        <p14:creationId xmlns:p14="http://schemas.microsoft.com/office/powerpoint/2010/main" val="1806502344"/>
       </p:ext>
     </p:extLst>
   </p:cSld>
@@ -2314,7 +2314,7 @@
           <p:cNvPr id="5" name="text-11">
             <a:extLst xmlns:a="http://schemas.openxmlformats.org/drawingml/2006/main">
               <a:ext uri="{FF2B5EF4-FFF2-40B4-BE49-F238E27FC236}">
-                <a16:creationId xmlns:a16="http://schemas.microsoft.com/office/drawing/2014/main" id="{85F51457-A9CF-4C8A-8505-92A03A4A5446}"/>
+                <a16:creationId xmlns:a16="http://schemas.microsoft.com/office/drawing/2014/main" id="{41FEBDA6-2A16-408F-BE58-A3D2EBFA62E7}"/>
               </a:ext>
             </a:extLst>
           </p:cNvPr>
@@ -2371,7 +2371,7 @@
           <p:cNvPr id="2" name="text-12">
             <a:extLst xmlns:a="http://schemas.openxmlformats.org/drawingml/2006/main">
               <a:ext uri="{FF2B5EF4-FFF2-40B4-BE49-F238E27FC236}">
-                <a16:creationId xmlns:a16="http://schemas.microsoft.com/office/drawing/2014/main" id="{D989C822-A71A-4597-B03B-A5BFA4231048}"/>
+                <a16:creationId xmlns:a16="http://schemas.microsoft.com/office/drawing/2014/main" id="{0F639676-59D5-42AF-AF9F-FEB5B3572A02}"/>
               </a:ext>
             </a:extLst>
           </p:cNvPr>
@@ -2747,7 +2747,7 @@
           <p:cNvPr id="4" name="text-13">
             <a:extLst xmlns:a="http://schemas.openxmlformats.org/drawingml/2006/main">
               <a:ext uri="{FF2B5EF4-FFF2-40B4-BE49-F238E27FC236}">
-                <a16:creationId xmlns:a16="http://schemas.microsoft.com/office/drawing/2014/main" id="{3CE038B3-A996-4063-AC0B-EF8C8EFBAF66}"/>
+                <a16:creationId xmlns:a16="http://schemas.microsoft.com/office/drawing/2014/main" id="{20121852-8C35-4FA8-B554-C7739A8316D4}"/>
               </a:ext>
             </a:extLst>
           </p:cNvPr>
@@ -2802,7 +2802,7 @@
     </p:spTree>
     <p:extLst>
       <p:ext uri="{BB962C8B-B14F-4D97-AF65-F5344CB8AC3E}">
-        <p14:creationId xmlns:p14="http://schemas.microsoft.com/office/powerpoint/2010/main" val="907259645"/>
+        <p14:creationId xmlns:p14="http://schemas.microsoft.com/office/powerpoint/2010/main" val="1846094360"/>
       </p:ext>
     </p:extLst>
   </p:cSld>
@@ -2833,7 +2833,7 @@
           <p:cNvPr id="7" name="text-14">
             <a:extLst xmlns:a="http://schemas.openxmlformats.org/drawingml/2006/main">
               <a:ext uri="{FF2B5EF4-FFF2-40B4-BE49-F238E27FC236}">
-                <a16:creationId xmlns:a16="http://schemas.microsoft.com/office/drawing/2014/main" id="{6CF3D6AC-BA04-4CAC-BBA0-5009389E1F81}"/>
+                <a16:creationId xmlns:a16="http://schemas.microsoft.com/office/drawing/2014/main" id="{3B3CB5C8-DB37-4A96-9139-ACCA82943A21}"/>
               </a:ext>
             </a:extLst>
           </p:cNvPr>
@@ -2890,7 +2890,7 @@
           <p:cNvPr id="2" name="text-15">
             <a:extLst xmlns:a="http://schemas.openxmlformats.org/drawingml/2006/main">
               <a:ext uri="{FF2B5EF4-FFF2-40B4-BE49-F238E27FC236}">
-                <a16:creationId xmlns:a16="http://schemas.microsoft.com/office/drawing/2014/main" id="{0D7B9F59-BED1-4388-B2FE-E66CFA8C89DA}"/>
+                <a16:creationId xmlns:a16="http://schemas.microsoft.com/office/drawing/2014/main" id="{6A70E18F-BE89-4AF9-AE30-03E33C59AAEF}"/>
               </a:ext>
             </a:extLst>
           </p:cNvPr>
@@ -2947,7 +2947,7 @@
           <p:cNvPr id="3" name="text-16">
             <a:extLst xmlns:a="http://schemas.openxmlformats.org/drawingml/2006/main">
               <a:ext uri="{FF2B5EF4-FFF2-40B4-BE49-F238E27FC236}">
-                <a16:creationId xmlns:a16="http://schemas.microsoft.com/office/drawing/2014/main" id="{3CC61EEC-2B03-45DD-A34D-746758EA21C1}"/>
+                <a16:creationId xmlns:a16="http://schemas.microsoft.com/office/drawing/2014/main" id="{AD88A1C3-630A-4CD8-B4B7-780887AA06C6}"/>
               </a:ext>
             </a:extLst>
           </p:cNvPr>
@@ -3004,7 +3004,7 @@
           <p:cNvPr id="4" name="text-17">
             <a:extLst xmlns:a="http://schemas.openxmlformats.org/drawingml/2006/main">
               <a:ext uri="{FF2B5EF4-FFF2-40B4-BE49-F238E27FC236}">
-                <a16:creationId xmlns:a16="http://schemas.microsoft.com/office/drawing/2014/main" id="{ADE070C6-BAD3-422B-8361-399D9B98C7DA}"/>
+                <a16:creationId xmlns:a16="http://schemas.microsoft.com/office/drawing/2014/main" id="{2BDED5FC-AC05-436C-807A-281D05384BD6}"/>
               </a:ext>
             </a:extLst>
           </p:cNvPr>
@@ -3061,7 +3061,7 @@
           <p:cNvPr id="5" name="text-18">
             <a:extLst xmlns:a="http://schemas.openxmlformats.org/drawingml/2006/main">
               <a:ext uri="{FF2B5EF4-FFF2-40B4-BE49-F238E27FC236}">
-                <a16:creationId xmlns:a16="http://schemas.microsoft.com/office/drawing/2014/main" id="{C9155967-F077-4A94-8EC1-71552418FF87}"/>
+                <a16:creationId xmlns:a16="http://schemas.microsoft.com/office/drawing/2014/main" id="{28E1D310-45CB-49B1-B2E4-0F65FAA0320C}"/>
               </a:ext>
             </a:extLst>
           </p:cNvPr>
@@ -3145,7 +3145,7 @@
           <p:nvPr/>
         </p:nvPicPr>
         <p:blipFill>
-          <a:blip xmlns:r="http://schemas.openxmlformats.org/officeDocument/2006/relationships" xmlns:a="http://schemas.openxmlformats.org/drawingml/2006/main" r:embed="R6a86596e0d194ca6"/>
+          <a:blip xmlns:r="http://schemas.openxmlformats.org/officeDocument/2006/relationships" xmlns:a="http://schemas.openxmlformats.org/drawingml/2006/main" r:embed="R9b7744e9c3df458b"/>
           <a:stretch xmlns:a="http://schemas.openxmlformats.org/drawingml/2006/main"/>
         </p:blipFill>
         <p:spPr>
@@ -3161,7 +3161,7 @@
     </p:spTree>
     <p:extLst>
       <p:ext uri="{BB962C8B-B14F-4D97-AF65-F5344CB8AC3E}">
-        <p14:creationId xmlns:p14="http://schemas.microsoft.com/office/powerpoint/2010/main" val="1897704430"/>
+        <p14:creationId xmlns:p14="http://schemas.microsoft.com/office/powerpoint/2010/main" val="10969866"/>
       </p:ext>
     </p:extLst>
   </p:cSld>
@@ -3192,7 +3192,7 @@
           <p:cNvPr id="6" name="text-19">
             <a:extLst xmlns:a="http://schemas.openxmlformats.org/drawingml/2006/main">
               <a:ext uri="{FF2B5EF4-FFF2-40B4-BE49-F238E27FC236}">
-                <a16:creationId xmlns:a16="http://schemas.microsoft.com/office/drawing/2014/main" id="{4654B7E5-A2B7-4F50-9185-858611A82CA6}"/>
+                <a16:creationId xmlns:a16="http://schemas.microsoft.com/office/drawing/2014/main" id="{73BF76AB-1563-4409-87FE-C01685C9FE8A}"/>
               </a:ext>
             </a:extLst>
           </p:cNvPr>
@@ -3249,7 +3249,7 @@
           <p:cNvPr id="2" name="text-20">
             <a:extLst xmlns:a="http://schemas.openxmlformats.org/drawingml/2006/main">
               <a:ext uri="{FF2B5EF4-FFF2-40B4-BE49-F238E27FC236}">
-                <a16:creationId xmlns:a16="http://schemas.microsoft.com/office/drawing/2014/main" id="{0648393B-14F5-4BA0-BE54-D251ED8A59BA}"/>
+                <a16:creationId xmlns:a16="http://schemas.microsoft.com/office/drawing/2014/main" id="{FF77A229-C18C-4BC8-B11E-B903535077DD}"/>
               </a:ext>
             </a:extLst>
           </p:cNvPr>
@@ -3624,7 +3624,7 @@
           <p:cNvPr id="4" name="text-21">
             <a:extLst xmlns:a="http://schemas.openxmlformats.org/drawingml/2006/main">
               <a:ext uri="{FF2B5EF4-FFF2-40B4-BE49-F238E27FC236}">
-                <a16:creationId xmlns:a16="http://schemas.microsoft.com/office/drawing/2014/main" id="{361C11BB-A0A5-4052-9D02-70B243397AAE}"/>
+                <a16:creationId xmlns:a16="http://schemas.microsoft.com/office/drawing/2014/main" id="{E4F2C419-1040-4D3A-8657-7C2DEFD76F5F}"/>
               </a:ext>
             </a:extLst>
           </p:cNvPr>
@@ -3681,7 +3681,7 @@
           <p:cNvPr id="5" name="text-22">
             <a:extLst xmlns:a="http://schemas.openxmlformats.org/drawingml/2006/main">
               <a:ext uri="{FF2B5EF4-FFF2-40B4-BE49-F238E27FC236}">
-                <a16:creationId xmlns:a16="http://schemas.microsoft.com/office/drawing/2014/main" id="{659DFF6C-A136-4105-BF27-EC6A4973CF44}"/>
+                <a16:creationId xmlns:a16="http://schemas.microsoft.com/office/drawing/2014/main" id="{DA727AB0-A9E4-4F71-9794-7FD6805D0830}"/>
               </a:ext>
             </a:extLst>
           </p:cNvPr>
@@ -3759,7 +3759,7 @@
     </p:spTree>
     <p:extLst>
       <p:ext uri="{BB962C8B-B14F-4D97-AF65-F5344CB8AC3E}">
-        <p14:creationId xmlns:p14="http://schemas.microsoft.com/office/powerpoint/2010/main" val="1019835127"/>
+        <p14:creationId xmlns:p14="http://schemas.microsoft.com/office/powerpoint/2010/main" val="1200001361"/>
       </p:ext>
     </p:extLst>
   </p:cSld>
@@ -3790,7 +3790,7 @@
           <p:cNvPr id="8" name="text-23">
             <a:extLst xmlns:a="http://schemas.openxmlformats.org/drawingml/2006/main">
               <a:ext uri="{FF2B5EF4-FFF2-40B4-BE49-F238E27FC236}">
-                <a16:creationId xmlns:a16="http://schemas.microsoft.com/office/drawing/2014/main" id="{AD6C5145-5F05-496B-8418-375B8F14DDF5}"/>
+                <a16:creationId xmlns:a16="http://schemas.microsoft.com/office/drawing/2014/main" id="{ECA5014B-1B35-47E8-869D-AACEAFC84EA5}"/>
               </a:ext>
             </a:extLst>
           </p:cNvPr>
@@ -3837,7 +3837,7 @@
                 <a:ea typeface="Helvetica Neue"/>
                 <a:cs typeface="Helvetica Neue"/>
               </a:rPr>
-              <a:t>IBM Bob repair handoff</a:t>
+              <a:t>IBM Bob repository validation</a:t>
             </a:r>
           </a:p>
         </p:txBody>
@@ -3847,7 +3847,7 @@
           <p:cNvPr id="2" name="text-24">
             <a:extLst xmlns:a="http://schemas.openxmlformats.org/drawingml/2006/main">
               <a:ext uri="{FF2B5EF4-FFF2-40B4-BE49-F238E27FC236}">
-                <a16:creationId xmlns:a16="http://schemas.microsoft.com/office/drawing/2014/main" id="{ACDE8443-1133-4700-9B0C-403AE91B5E45}"/>
+                <a16:creationId xmlns:a16="http://schemas.microsoft.com/office/drawing/2014/main" id="{3BF796D0-DDF2-4DA2-9151-59D6F0C56A52}"/>
               </a:ext>
             </a:extLst>
           </p:cNvPr>
@@ -3904,7 +3904,7 @@
           <p:cNvPr id="3" name="text-25">
             <a:extLst xmlns:a="http://schemas.openxmlformats.org/drawingml/2006/main">
               <a:ext uri="{FF2B5EF4-FFF2-40B4-BE49-F238E27FC236}">
-                <a16:creationId xmlns:a16="http://schemas.microsoft.com/office/drawing/2014/main" id="{E02D68FD-13FA-49E7-9EFF-DD85BE6B1E14}"/>
+                <a16:creationId xmlns:a16="http://schemas.microsoft.com/office/drawing/2014/main" id="{01C62A75-DFD0-4828-897D-8F40C6EB3FE9}"/>
               </a:ext>
             </a:extLst>
           </p:cNvPr>
@@ -3951,7 +3951,7 @@
                 <a:ea typeface="Helvetica Neue"/>
                 <a:cs typeface="Helvetica Neue"/>
               </a:rPr>
-              <a:t>1  Export the failure</a:t>
+              <a:t>1  Source-derived regression tests</a:t>
             </a:r>
           </a:p>
         </p:txBody>
@@ -3961,7 +3961,7 @@
           <p:cNvPr id="4" name="text-26">
             <a:extLst xmlns:a="http://schemas.openxmlformats.org/drawingml/2006/main">
               <a:ext uri="{FF2B5EF4-FFF2-40B4-BE49-F238E27FC236}">
-                <a16:creationId xmlns:a16="http://schemas.microsoft.com/office/drawing/2014/main" id="{1E5F3B9E-FD27-41F6-84A6-0FEB33B5F979}"/>
+                <a16:creationId xmlns:a16="http://schemas.microsoft.com/office/drawing/2014/main" id="{A2F1E14D-7035-4F68-B3ED-A97FE642F55A}"/>
               </a:ext>
             </a:extLst>
           </p:cNvPr>
@@ -3973,7 +3973,7 @@
         <p:spPr>
           <a:xfrm xmlns:a="http://schemas.openxmlformats.org/drawingml/2006/main">
             <a:off x="1162050" y="2771775"/>
-            <a:ext cx="9906000" cy="600075"/>
+            <a:ext cx="9906000" cy="952500"/>
           </a:xfrm>
           <a:prstGeom xmlns:a="http://schemas.openxmlformats.org/drawingml/2006/main" prst="rect">
             <a:avLst/>
@@ -4008,7 +4008,30 @@
                 <a:ea typeface="Helvetica Neue"/>
                 <a:cs typeface="Helvetica Neue"/>
               </a:rPr>
-              <a:t>Exact contract, executed SQL and data differences</a:t>
+              <a:t>41 checks cover the checkout contract, silent data loss,</a:t>
+            </a:r>
+          </a:p>
+          <a:p xmlns:a="http://schemas.openxmlformats.org/drawingml/2006/main">
+            <a:pPr>
+              <a:defRPr sz="2400" b="0">
+                <a:solidFill>
+                  <a:srgbClr val="25251F"/>
+                </a:solidFill>
+                <a:latin typeface="Helvetica Neue"/>
+                <a:ea typeface="Helvetica Neue"/>
+                <a:cs typeface="Helvetica Neue"/>
+              </a:defRPr>
+            </a:pPr>
+            <a:r>
+              <a:rPr sz="2400" b="0">
+                <a:solidFill>
+                  <a:srgbClr val="25251F"/>
+                </a:solidFill>
+                <a:latin typeface="Helvetica Neue"/>
+                <a:ea typeface="Helvetica Neue"/>
+                <a:cs typeface="Helvetica Neue"/>
+              </a:rPr>
+              <a:t>and the unchanged repair invariant.</a:t>
             </a:r>
           </a:p>
         </p:txBody>
@@ -4018,7 +4041,7 @@
           <p:cNvPr id="5" name="text-27">
             <a:extLst xmlns:a="http://schemas.openxmlformats.org/drawingml/2006/main">
               <a:ext uri="{FF2B5EF4-FFF2-40B4-BE49-F238E27FC236}">
-                <a16:creationId xmlns:a16="http://schemas.microsoft.com/office/drawing/2014/main" id="{65C18FEB-B7AF-4998-BE99-9B99E619A499}"/>
+                <a16:creationId xmlns:a16="http://schemas.microsoft.com/office/drawing/2014/main" id="{EB552420-4E6C-4140-8FB6-B2231FFCB221}"/>
               </a:ext>
             </a:extLst>
           </p:cNvPr>
@@ -4065,7 +4088,7 @@
                 <a:ea typeface="Helvetica Neue"/>
                 <a:cs typeface="Helvetica Neue"/>
               </a:rPr>
-              <a:t>2  Review a repair in Bob IDE</a:t>
+              <a:t>2  Real PostgreSQL validation</a:t>
             </a:r>
           </a:p>
         </p:txBody>
@@ -4075,7 +4098,7 @@
           <p:cNvPr id="6" name="text-28">
             <a:extLst xmlns:a="http://schemas.openxmlformats.org/drawingml/2006/main">
               <a:ext uri="{FF2B5EF4-FFF2-40B4-BE49-F238E27FC236}">
-                <a16:creationId xmlns:a16="http://schemas.microsoft.com/office/drawing/2014/main" id="{D0D4B4C7-391B-4186-8381-622920EF5027}"/>
+                <a16:creationId xmlns:a16="http://schemas.microsoft.com/office/drawing/2014/main" id="{3585238D-18C2-4B90-8B86-8B4DA8301170}"/>
               </a:ext>
             </a:extLst>
           </p:cNvPr>
@@ -4122,7 +4145,7 @@
                 <a:ea typeface="Helvetica Neue"/>
                 <a:cs typeface="Helvetica Neue"/>
               </a:rPr>
-              <a:t>Use repository context. Inspect the change. Rehearse again.</a:t>
+              <a:t>Bob ran the new suite in the repository using PGlite.</a:t>
             </a:r>
           </a:p>
         </p:txBody>
@@ -4132,7 +4155,7 @@
           <p:cNvPr id="7" name="text-29">
             <a:extLst xmlns:a="http://schemas.openxmlformats.org/drawingml/2006/main">
               <a:ext uri="{FF2B5EF4-FFF2-40B4-BE49-F238E27FC236}">
-                <a16:creationId xmlns:a16="http://schemas.microsoft.com/office/drawing/2014/main" id="{B891E93A-4592-41E2-AD59-3D8DFDEDC093}"/>
+                <a16:creationId xmlns:a16="http://schemas.microsoft.com/office/drawing/2014/main" id="{56C0BAA2-94AE-4DD1-9F91-22DE7FFC35F6}"/>
               </a:ext>
             </a:extLst>
           </p:cNvPr>
@@ -4179,7 +4202,7 @@
                 <a:ea typeface="Helvetica Neue"/>
                 <a:cs typeface="Helvetica Neue"/>
               </a:rPr>
-              <a:t>Manual handoff. Supplied sample repairs are authored examples.</a:t>
+              <a:t>Scoped Bob testing contribution. Sample repairs remain authored examples.</a:t>
             </a:r>
           </a:p>
         </p:txBody>
@@ -4187,7 +4210,7 @@
     </p:spTree>
     <p:extLst>
       <p:ext uri="{BB962C8B-B14F-4D97-AF65-F5344CB8AC3E}">
-        <p14:creationId xmlns:p14="http://schemas.microsoft.com/office/powerpoint/2010/main" val="774830535"/>
+        <p14:creationId xmlns:p14="http://schemas.microsoft.com/office/powerpoint/2010/main" val="396736672"/>
       </p:ext>
     </p:extLst>
   </p:cSld>
@@ -4218,7 +4241,7 @@
           <p:cNvPr id="12" name="text-30">
             <a:extLst xmlns:a="http://schemas.openxmlformats.org/drawingml/2006/main">
               <a:ext uri="{FF2B5EF4-FFF2-40B4-BE49-F238E27FC236}">
-                <a16:creationId xmlns:a16="http://schemas.microsoft.com/office/drawing/2014/main" id="{02FB4335-F515-45E9-993D-B32B6B33C960}"/>
+                <a16:creationId xmlns:a16="http://schemas.microsoft.com/office/drawing/2014/main" id="{12F0B068-2FAD-4891-882F-2A79E5690FB7}"/>
               </a:ext>
             </a:extLst>
           </p:cNvPr>
@@ -4275,7 +4298,7 @@
           <p:cNvPr id="2" name="text-31">
             <a:extLst xmlns:a="http://schemas.openxmlformats.org/drawingml/2006/main">
               <a:ext uri="{FF2B5EF4-FFF2-40B4-BE49-F238E27FC236}">
-                <a16:creationId xmlns:a16="http://schemas.microsoft.com/office/drawing/2014/main" id="{CC1FC9C5-2632-41CD-9578-79E2F588AF2F}"/>
+                <a16:creationId xmlns:a16="http://schemas.microsoft.com/office/drawing/2014/main" id="{F470C589-0C04-466E-A982-9D905981184F}"/>
               </a:ext>
             </a:extLst>
           </p:cNvPr>
@@ -4332,7 +4355,7 @@
           <p:cNvPr id="3" name="text-32">
             <a:extLst xmlns:a="http://schemas.openxmlformats.org/drawingml/2006/main">
               <a:ext uri="{FF2B5EF4-FFF2-40B4-BE49-F238E27FC236}">
-                <a16:creationId xmlns:a16="http://schemas.microsoft.com/office/drawing/2014/main" id="{4418438C-867A-4AC3-A12B-24F0DFC8378F}"/>
+                <a16:creationId xmlns:a16="http://schemas.microsoft.com/office/drawing/2014/main" id="{8593598E-61CF-4835-831B-41984CDF3B92}"/>
               </a:ext>
             </a:extLst>
           </p:cNvPr>
@@ -4389,7 +4412,7 @@
           <p:cNvPr id="4" name="text-33">
             <a:extLst xmlns:a="http://schemas.openxmlformats.org/drawingml/2006/main">
               <a:ext uri="{FF2B5EF4-FFF2-40B4-BE49-F238E27FC236}">
-                <a16:creationId xmlns:a16="http://schemas.microsoft.com/office/drawing/2014/main" id="{69F4B9DA-F4B7-48B6-85FC-660A77E7CC92}"/>
+                <a16:creationId xmlns:a16="http://schemas.microsoft.com/office/drawing/2014/main" id="{6F777A74-734E-4FD0-956D-30D179529255}"/>
               </a:ext>
             </a:extLst>
           </p:cNvPr>
@@ -4469,7 +4492,7 @@
           <p:cNvPr id="5" name="text-34">
             <a:extLst xmlns:a="http://schemas.openxmlformats.org/drawingml/2006/main">
               <a:ext uri="{FF2B5EF4-FFF2-40B4-BE49-F238E27FC236}">
-                <a16:creationId xmlns:a16="http://schemas.microsoft.com/office/drawing/2014/main" id="{967E2A04-6314-4D87-8C30-BD0397344F50}"/>
+                <a16:creationId xmlns:a16="http://schemas.microsoft.com/office/drawing/2014/main" id="{3C4F79B4-3818-4254-B6B8-BC87BB3E7A33}"/>
               </a:ext>
             </a:extLst>
           </p:cNvPr>
@@ -4526,7 +4549,7 @@
           <p:cNvPr id="6" name="text-35">
             <a:extLst xmlns:a="http://schemas.openxmlformats.org/drawingml/2006/main">
               <a:ext uri="{FF2B5EF4-FFF2-40B4-BE49-F238E27FC236}">
-                <a16:creationId xmlns:a16="http://schemas.microsoft.com/office/drawing/2014/main" id="{B15C4E05-6E33-4E0C-ACED-4B3DBBB8AAC5}"/>
+                <a16:creationId xmlns:a16="http://schemas.microsoft.com/office/drawing/2014/main" id="{1B6CDA71-8847-495D-9171-4DEA11FA7E2D}"/>
               </a:ext>
             </a:extLst>
           </p:cNvPr>
@@ -4606,7 +4629,7 @@
           <p:cNvPr id="7" name="text-36">
             <a:extLst xmlns:a="http://schemas.openxmlformats.org/drawingml/2006/main">
               <a:ext uri="{FF2B5EF4-FFF2-40B4-BE49-F238E27FC236}">
-                <a16:creationId xmlns:a16="http://schemas.microsoft.com/office/drawing/2014/main" id="{7515A2ED-1096-4167-BD2A-EB719AC3D64A}"/>
+                <a16:creationId xmlns:a16="http://schemas.microsoft.com/office/drawing/2014/main" id="{855D47F7-F7BE-45A4-9BBC-078B8278DFE4}"/>
               </a:ext>
             </a:extLst>
           </p:cNvPr>
@@ -4663,7 +4686,7 @@
           <p:cNvPr id="8" name="text-37">
             <a:extLst xmlns:a="http://schemas.openxmlformats.org/drawingml/2006/main">
               <a:ext uri="{FF2B5EF4-FFF2-40B4-BE49-F238E27FC236}">
-                <a16:creationId xmlns:a16="http://schemas.microsoft.com/office/drawing/2014/main" id="{917928BA-8A37-486A-AC74-AAD4B65F9383}"/>
+                <a16:creationId xmlns:a16="http://schemas.microsoft.com/office/drawing/2014/main" id="{5B3013FC-C1A2-4EC4-BA6E-289203232C66}"/>
               </a:ext>
             </a:extLst>
           </p:cNvPr>
@@ -4720,7 +4743,7 @@
           <p:cNvPr id="9" name="text-38">
             <a:extLst xmlns:a="http://schemas.openxmlformats.org/drawingml/2006/main">
               <a:ext uri="{FF2B5EF4-FFF2-40B4-BE49-F238E27FC236}">
-                <a16:creationId xmlns:a16="http://schemas.microsoft.com/office/drawing/2014/main" id="{4B884D77-811B-46DA-87F1-315819DD3B71}"/>
+                <a16:creationId xmlns:a16="http://schemas.microsoft.com/office/drawing/2014/main" id="{E8A6E1B0-09DD-41C8-B2E9-D0DB9611F58D}"/>
               </a:ext>
             </a:extLst>
           </p:cNvPr>
@@ -4777,7 +4800,7 @@
           <p:cNvPr id="10" name="text-39">
             <a:extLst xmlns:a="http://schemas.openxmlformats.org/drawingml/2006/main">
               <a:ext uri="{FF2B5EF4-FFF2-40B4-BE49-F238E27FC236}">
-                <a16:creationId xmlns:a16="http://schemas.microsoft.com/office/drawing/2014/main" id="{EDAB5572-DE8E-4B47-ACBC-7C5033A43885}"/>
+                <a16:creationId xmlns:a16="http://schemas.microsoft.com/office/drawing/2014/main" id="{17929FF9-6410-4D21-83DA-A6F20B74DB4A}"/>
               </a:ext>
             </a:extLst>
           </p:cNvPr>
@@ -4857,7 +4880,7 @@
           <p:cNvPr id="11" name="text-40">
             <a:extLst xmlns:a="http://schemas.openxmlformats.org/drawingml/2006/main">
               <a:ext uri="{FF2B5EF4-FFF2-40B4-BE49-F238E27FC236}">
-                <a16:creationId xmlns:a16="http://schemas.microsoft.com/office/drawing/2014/main" id="{B91C09E3-EFEE-4769-BD7E-F3C2A81CDAAF}"/>
+                <a16:creationId xmlns:a16="http://schemas.microsoft.com/office/drawing/2014/main" id="{A04BEC25-5DC4-44AD-BECC-8C7EA9C89440}"/>
               </a:ext>
             </a:extLst>
           </p:cNvPr>
@@ -4912,7 +4935,7 @@
     </p:spTree>
     <p:extLst>
       <p:ext uri="{BB962C8B-B14F-4D97-AF65-F5344CB8AC3E}">
-        <p14:creationId xmlns:p14="http://schemas.microsoft.com/office/powerpoint/2010/main" val="258465082"/>
+        <p14:creationId xmlns:p14="http://schemas.microsoft.com/office/powerpoint/2010/main" val="2023008592"/>
       </p:ext>
     </p:extLst>
   </p:cSld>
@@ -4943,7 +4966,7 @@
           <p:cNvPr id="6" name="text-41">
             <a:extLst xmlns:a="http://schemas.openxmlformats.org/drawingml/2006/main">
               <a:ext uri="{FF2B5EF4-FFF2-40B4-BE49-F238E27FC236}">
-                <a16:creationId xmlns:a16="http://schemas.microsoft.com/office/drawing/2014/main" id="{0654CF0E-925C-4307-B87C-FA356B07E6EC}"/>
+                <a16:creationId xmlns:a16="http://schemas.microsoft.com/office/drawing/2014/main" id="{CE7B714D-AA16-4A6C-BE9F-D318F894FA12}"/>
               </a:ext>
             </a:extLst>
           </p:cNvPr>
@@ -5000,7 +5023,7 @@
           <p:cNvPr id="2" name="text-42">
             <a:extLst xmlns:a="http://schemas.openxmlformats.org/drawingml/2006/main">
               <a:ext uri="{FF2B5EF4-FFF2-40B4-BE49-F238E27FC236}">
-                <a16:creationId xmlns:a16="http://schemas.microsoft.com/office/drawing/2014/main" id="{F7A3EC50-7EF6-4EB9-A5E7-8D85CDCD0595}"/>
+                <a16:creationId xmlns:a16="http://schemas.microsoft.com/office/drawing/2014/main" id="{7145742E-E520-48F5-BA94-E2081A4C83ED}"/>
               </a:ext>
             </a:extLst>
           </p:cNvPr>
@@ -5057,7 +5080,7 @@
           <p:cNvPr id="3" name="text-43">
             <a:extLst xmlns:a="http://schemas.openxmlformats.org/drawingml/2006/main">
               <a:ext uri="{FF2B5EF4-FFF2-40B4-BE49-F238E27FC236}">
-                <a16:creationId xmlns:a16="http://schemas.microsoft.com/office/drawing/2014/main" id="{223B0E6F-EE48-4621-83EE-FC910FE90CAF}"/>
+                <a16:creationId xmlns:a16="http://schemas.microsoft.com/office/drawing/2014/main" id="{2D3A94B5-1D79-4A86-8D06-5BE407CABFBF}"/>
               </a:ext>
             </a:extLst>
           </p:cNvPr>
@@ -5137,7 +5160,7 @@
           <p:cNvPr id="4" name="text-44">
             <a:extLst xmlns:a="http://schemas.openxmlformats.org/drawingml/2006/main">
               <a:ext uri="{FF2B5EF4-FFF2-40B4-BE49-F238E27FC236}">
-                <a16:creationId xmlns:a16="http://schemas.microsoft.com/office/drawing/2014/main" id="{95DB04F0-DB93-4852-A31E-52652B2A15D4}"/>
+                <a16:creationId xmlns:a16="http://schemas.microsoft.com/office/drawing/2014/main" id="{954EB757-D1E6-4E4B-890F-52DCF4960F2C}"/>
               </a:ext>
             </a:extLst>
           </p:cNvPr>
@@ -5217,7 +5240,7 @@
           <p:cNvPr id="5" name="text-45">
             <a:extLst xmlns:a="http://schemas.openxmlformats.org/drawingml/2006/main">
               <a:ext uri="{FF2B5EF4-FFF2-40B4-BE49-F238E27FC236}">
-                <a16:creationId xmlns:a16="http://schemas.microsoft.com/office/drawing/2014/main" id="{001DF5B9-BA26-42EA-AEFB-E70CFE077C6A}"/>
+                <a16:creationId xmlns:a16="http://schemas.microsoft.com/office/drawing/2014/main" id="{6D17CE45-44F6-442A-87AB-91AA5BFEBBBB}"/>
               </a:ext>
             </a:extLst>
           </p:cNvPr>
@@ -5295,7 +5318,7 @@
     </p:spTree>
     <p:extLst>
       <p:ext uri="{BB962C8B-B14F-4D97-AF65-F5344CB8AC3E}">
-        <p14:creationId xmlns:p14="http://schemas.microsoft.com/office/powerpoint/2010/main" val="230211673"/>
+        <p14:creationId xmlns:p14="http://schemas.microsoft.com/office/powerpoint/2010/main" val="2088357669"/>
       </p:ext>
     </p:extLst>
   </p:cSld>
@@ -5326,7 +5349,7 @@
           <p:cNvPr id="7" name="text-46">
             <a:extLst xmlns:a="http://schemas.openxmlformats.org/drawingml/2006/main">
               <a:ext uri="{FF2B5EF4-FFF2-40B4-BE49-F238E27FC236}">
-                <a16:creationId xmlns:a16="http://schemas.microsoft.com/office/drawing/2014/main" id="{E49A0CD3-CB73-4795-8C88-9DB8A9B67E9E}"/>
+                <a16:creationId xmlns:a16="http://schemas.microsoft.com/office/drawing/2014/main" id="{50836C6A-823D-4175-8203-B26BCE195720}"/>
               </a:ext>
             </a:extLst>
           </p:cNvPr>
@@ -5383,7 +5406,7 @@
           <p:cNvPr id="2" name="text-47">
             <a:extLst xmlns:a="http://schemas.openxmlformats.org/drawingml/2006/main">
               <a:ext uri="{FF2B5EF4-FFF2-40B4-BE49-F238E27FC236}">
-                <a16:creationId xmlns:a16="http://schemas.microsoft.com/office/drawing/2014/main" id="{AB80EAB8-FFDA-49B4-9112-8D7F8C2DBE73}"/>
+                <a16:creationId xmlns:a16="http://schemas.microsoft.com/office/drawing/2014/main" id="{C0F479A2-B1A5-4859-AC36-E7C768D53F14}"/>
               </a:ext>
             </a:extLst>
           </p:cNvPr>
@@ -5463,7 +5486,7 @@
           <p:cNvPr id="3" name="text-48">
             <a:extLst xmlns:a="http://schemas.openxmlformats.org/drawingml/2006/main">
               <a:ext uri="{FF2B5EF4-FFF2-40B4-BE49-F238E27FC236}">
-                <a16:creationId xmlns:a16="http://schemas.microsoft.com/office/drawing/2014/main" id="{3D5C3AFE-5595-4B18-969A-D104BBCD4290}"/>
+                <a16:creationId xmlns:a16="http://schemas.microsoft.com/office/drawing/2014/main" id="{30F28C61-D196-455C-A5CB-E2C8C5E11CD4}"/>
               </a:ext>
             </a:extLst>
           </p:cNvPr>
@@ -5520,7 +5543,7 @@
           <p:cNvPr id="4" name="text-49">
             <a:extLst xmlns:a="http://schemas.openxmlformats.org/drawingml/2006/main">
               <a:ext uri="{FF2B5EF4-FFF2-40B4-BE49-F238E27FC236}">
-                <a16:creationId xmlns:a16="http://schemas.microsoft.com/office/drawing/2014/main" id="{3C5058AC-C6B8-4573-83EE-F55A14708ECD}"/>
+                <a16:creationId xmlns:a16="http://schemas.microsoft.com/office/drawing/2014/main" id="{515FCE58-9680-43F7-A72E-4D988A7664E4}"/>
               </a:ext>
             </a:extLst>
           </p:cNvPr>
@@ -5567,7 +5590,7 @@
                 <a:ea typeface="Helvetica Neue"/>
                 <a:cs typeface="Helvetica Neue"/>
               </a:rPr>
-              <a:t>shi1720.github.io/ibm-bob</a:t>
+              <a:t>undoproof.web.app</a:t>
             </a:r>
           </a:p>
         </p:txBody>
@@ -5577,7 +5600,7 @@
           <p:cNvPr id="5" name="text-50">
             <a:extLst xmlns:a="http://schemas.openxmlformats.org/drawingml/2006/main">
               <a:ext uri="{FF2B5EF4-FFF2-40B4-BE49-F238E27FC236}">
-                <a16:creationId xmlns:a16="http://schemas.microsoft.com/office/drawing/2014/main" id="{79D779ED-6E24-4C23-921E-A52ED0369E64}"/>
+                <a16:creationId xmlns:a16="http://schemas.microsoft.com/office/drawing/2014/main" id="{AB7D75E4-C010-4AD7-827A-D4072A843351}"/>
               </a:ext>
             </a:extLst>
           </p:cNvPr>
@@ -5634,7 +5657,7 @@
           <p:cNvPr id="6" name="text-51">
             <a:extLst xmlns:a="http://schemas.openxmlformats.org/drawingml/2006/main">
               <a:ext uri="{FF2B5EF4-FFF2-40B4-BE49-F238E27FC236}">
-                <a16:creationId xmlns:a16="http://schemas.microsoft.com/office/drawing/2014/main" id="{F9CB0BD3-6846-47A5-B1A0-8AAAA60FF541}"/>
+                <a16:creationId xmlns:a16="http://schemas.microsoft.com/office/drawing/2014/main" id="{D26D61FD-219F-456B-A3AE-063027318ACC}"/>
               </a:ext>
             </a:extLst>
           </p:cNvPr>
@@ -5689,7 +5712,7 @@
     </p:spTree>
     <p:extLst>
       <p:ext uri="{BB962C8B-B14F-4D97-AF65-F5344CB8AC3E}">
-        <p14:creationId xmlns:p14="http://schemas.microsoft.com/office/powerpoint/2010/main" val="2023730419"/>
+        <p14:creationId xmlns:p14="http://schemas.microsoft.com/office/powerpoint/2010/main" val="1090337671"/>
       </p:ext>
     </p:extLst>
   </p:cSld>

</xml_diff>